<commit_message>
Deck: correct blast-radius numbers to verified demo (2 sessions, 3 volunteers)
</commit_message>
<xml_diff>
--- a/Sanchalan_KBC2026_Pitch.pptx
+++ b/Sanchalan_KBC2026_Pitch.pptx
@@ -2903,7 +2903,7 @@
                 </a:solidFill>
                 <a:latin typeface="Calibri"/>
               </a:rPr>
-              <a:t>AI output: structured change {venue_change} + blast radius: 4 sessions, 5 volunteers, 3 tasks, 1 P0 capacity risk.</a:t>
+              <a:t>AI output: structured change {venue_change} + blast radius: 2 sessions moved (Opening Keynote, Panel: Fundraising 101), 3 volunteers flagged, 3 tasks rewritten, 1 P0 capacity risk (Seminar Hall B holds 120 vs ~200 attendees).</a:t>
             </a:r>
           </a:p>
           <a:p>
@@ -5042,7 +5042,7 @@
                 </a:solidFill>
                 <a:latin typeface="Calibri"/>
               </a:rPr>
-              <a:t>2. System parses → simulates: 4 sessions moved, P0 capacity risk (120 &lt; 200 attendees), 3 tasks rewritten, comms draft created → applies to Notion live.</a:t>
+              <a:t>2. System parses → simulates: 2 sessions moved (Opening Keynote, Panel: Fundraising 101), P0 capacity risk (120 &lt; 200 attendees), 3 tasks rewritten, 3 volunteers flagged, comms draft created → applies to Notion live.</a:t>
             </a:r>
           </a:p>
           <a:p>

</xml_diff>